<commit_message>
feat(pitch): add the social systems dimension per mentor guidance
A mentor (echoing the systems-leadership panel) flagged that judging weights the
holistic, social systems lens — social justice, externalities like displacement
and job loss, negative feedback loops, and unintended consequences — and pointed
to Stroh's "Systems Thinking for Social Change".

- slide 4: add the social-cost layer (livelihood, jobs, debt, displacement;
  hitting the most vulnerable hardest)
- systems now spans two slides: "Root cause, not symptom" names the Shifting the
  Burden archetype and reverses the vicious social loop into the virtuous one
  (the leverage point); "Designed for the whole system" covers resilience,
  fairness by design, and the unintended consequences we designed against
- pitch-script: reworked money + systems beats to match; add equity, redlining,
  and displacement answers to Q&A
- deck is now 11 slides
</commit_message>
<xml_diff>
--- a/docs/BanjirKawan.pptx
+++ b/docs/BanjirKawan.pptx
@@ -15,6 +15,7 @@
     <p:sldId id="263" r:id="rId15"/>
     <p:sldId id="264" r:id="rId16"/>
     <p:sldId id="265" r:id="rId17"/>
+    <p:sldId id="266" r:id="rId18"/>
   </p:sldIdLst>
   <p:sldSz cx="12191695" cy="6858000" type="screen4x3"/>
   <p:notesSz cx="6858000" cy="9144000"/>
@@ -581,6 +582,76 @@
           <a:lstStyle/>
           <a:p>
             <a:r>
+              <a:t>And because a flood is a whole system, we designed for the whole system — not just the shop. Resilient: if the data feed dies a watchdog tells every shop to treat heavy rain as a warning; if the network dies the earliest tier already fired and there's a paper plan on the wall — three channels, Telegram, SMS and paper, because the fix needs power, phones and roads too. Fair by design: the insurer-and-council funding subsidises the shops least able to pay, and the owner owns their data — because a warning you need resources to act on is regressive. And we named the unintended consequences and designed against them: insurers could use risk data to redline and drop the most exposed — so we sell resilience and verified claims, not risk-scoring for exclusion, and we keep the data owner-owned; a digital divide — so SMS and paper; alert fatigue and dependency — so tiered alerts with a debounce and the owner always in control. A systems approach means anticipating the harm, not just the good.</a:t>
+            </a:r>
+          </a:p>
+        </p:txBody>
+      </p:sp>
+      <p:sp>
+        <p:nvSpPr>
+          <p:cNvPr id="4" name="Slide Number Placeholder 3"/>
+          <p:cNvSpPr>
+            <a:spLocks noGrp="1"/>
+          </p:cNvSpPr>
+          <p:nvPr>
+            <p:ph type="sldNum" idx="5" sz="quarter"/>
+          </p:nvPr>
+        </p:nvSpPr>
+        <p:spPr/>
+      </p:sp>
+    </p:spTree>
+  </p:cSld>
+  <p:clrMapOvr>
+    <a:masterClrMapping/>
+  </p:clrMapOvr>
+</p:notes>
+</file>
+
+<file path=ppt/notesSlides/notesSlide11.xml><?xml version="1.0" encoding="utf-8"?>
+<p:notes xmlns:a="http://schemas.openxmlformats.org/drawingml/2006/main" xmlns:p="http://schemas.openxmlformats.org/presentationml/2006/main" xmlns:r="http://schemas.openxmlformats.org/officeDocument/2006/relationships">
+  <p:cSld>
+    <p:spTree>
+      <p:nvGrpSpPr>
+        <p:cNvPr id="1" name=""/>
+        <p:cNvGrpSpPr/>
+        <p:nvPr/>
+      </p:nvGrpSpPr>
+      <p:grpSpPr>
+        <a:xfrm>
+          <a:off x="0" y="0"/>
+          <a:ext cx="0" cy="0"/>
+          <a:chOff x="0" y="0"/>
+          <a:chExt cx="0" cy="0"/>
+        </a:xfrm>
+      </p:grpSpPr>
+      <p:sp>
+        <p:nvSpPr>
+          <p:cNvPr id="2" name="Slide Image Placeholder 1"/>
+          <p:cNvSpPr>
+            <a:spLocks noGrp="1"/>
+          </p:cNvSpPr>
+          <p:nvPr>
+            <p:ph type="sldImg" idx="2"/>
+          </p:nvPr>
+        </p:nvSpPr>
+        <p:spPr/>
+      </p:sp>
+      <p:sp>
+        <p:nvSpPr>
+          <p:cNvPr id="3" name="Notes Placeholder 2"/>
+          <p:cNvSpPr>
+            <a:spLocks noGrp="1"/>
+          </p:cNvSpPr>
+          <p:nvPr>
+            <p:ph type="body" idx="3" sz="quarter"/>
+          </p:nvPr>
+        </p:nvSpPr>
+        <p:spPr/>
+        <p:txBody>
+          <a:bodyPr/>
+          <a:lstStyle/>
+          <a:p>
+            <a:r>
               <a:t>One place. One broken link — the last metre. One intervention, and we've already built it, deployed it, and put a business around it. Every flood warning becomes a shop's personal survival plan, and every survival plan becomes its claim evidence. The rivers are already telling us. BanjirKawan makes sure Kak Ros hears it in time — and gets paid after. Terima kasih.</a:t>
             </a:r>
           </a:p>
@@ -1141,7 +1212,7 @@
           <a:lstStyle/>
           <a:p>
             <a:r>
-              <a:t>Three things make this a resilient system, not just an app. Feedback loops: every completed checklist teaches us which actions owners actually take — a balancing loop that tightens the playbook each monsoon; every claim we get paid builds the trust that brings the next shop in — a reinforcing loop. It gets smarter and bigger from use. Designed for the worst day, not the average: feed dies, a watchdog tells every shop to treat heavy rain as a warning; network dies, the earliest tier already fired hours before the water, and there's a laminated plan on the wall. That's the brief's power-phones-roads point answered with three channels — Telegram, SMS, and paper. No single point of failure decides whether Kak Ros acts.</a:t>
+              <a:t>Now the systems core. Today's response pays out after the flood — relief and loans. In systems terms that's the 'Shifting the Burden' archetype: leaning on the symptomatic quick fix lets real resilience wither, so the problem keeps returning. And it drives a vicious reinforcing loop — a flood causes loss, loss forces debt, debt thins the buffer, so the next flood hits harder, until the shop closes or the family is displaced and the neighbourhood loses its shop. That loop falls first on those least able to absorb it — the uninsured, the informal, women-run micro-businesses like Kak Ros. This is where fairness meets systems. Our move is to shift the intervention upstream and reverse the loop: an early warning drives action, action means less loss, less loss plus telemetry-backed evidence means a faster payout, that builds trust, trust brings more shops, more shops means better data and better playbooks. Same loop, run the other way. That's the leverage point.</a:t>
             </a:r>
           </a:p>
         </p:txBody>
@@ -4328,6 +4399,596 @@
             <a:avLst/>
           </a:prstGeom>
           <a:solidFill>
+            <a:srgbClr val="FFFFFF"/>
+          </a:solidFill>
+          <a:ln>
+            <a:noFill/>
+          </a:ln>
+        </p:spPr>
+        <p:style>
+          <a:lnRef idx="1">
+            <a:schemeClr val="accent1"/>
+          </a:lnRef>
+          <a:fillRef idx="3">
+            <a:schemeClr val="accent1"/>
+          </a:fillRef>
+          <a:effectRef idx="2">
+            <a:schemeClr val="accent1"/>
+          </a:effectRef>
+          <a:fontRef idx="minor">
+            <a:schemeClr val="lt1"/>
+          </a:fontRef>
+        </p:style>
+        <p:txBody>
+          <a:bodyPr rtlCol="0" anchor="ctr"/>
+          <a:lstStyle/>
+          <a:p>
+            <a:pPr algn="ctr"/>
+          </a:p>
+        </p:txBody>
+      </p:sp>
+      <p:sp>
+        <p:nvSpPr>
+          <p:cNvPr id="3" name="TextBox 2"/>
+          <p:cNvSpPr txBox="1"/>
+          <p:nvPr/>
+        </p:nvSpPr>
+        <p:spPr>
+          <a:xfrm>
+            <a:off x="548640" y="411480"/>
+            <a:ext cx="11091672" cy="822960"/>
+          </a:xfrm>
+          <a:prstGeom prst="rect">
+            <a:avLst/>
+          </a:prstGeom>
+          <a:noFill/>
+        </p:spPr>
+        <p:txBody>
+          <a:bodyPr wrap="square" anchor="t">
+            <a:spAutoFit/>
+          </a:bodyPr>
+          <a:lstStyle/>
+          <a:p>
+            <a:pPr algn="l"/>
+            <a:r>
+              <a:rPr sz="4000" b="1" i="0">
+                <a:solidFill>
+                  <a:srgbClr val="0F172A"/>
+                </a:solidFill>
+                <a:latin typeface="Calibri"/>
+              </a:rPr>
+              <a:t>Designed for the whole system</a:t>
+            </a:r>
+          </a:p>
+        </p:txBody>
+      </p:sp>
+      <p:sp>
+        <p:nvSpPr>
+          <p:cNvPr id="4" name="Rounded Rectangle 3"/>
+          <p:cNvSpPr/>
+          <p:nvPr/>
+        </p:nvSpPr>
+        <p:spPr>
+          <a:xfrm>
+            <a:off x="548640" y="1645920"/>
+            <a:ext cx="3566160" cy="4114800"/>
+          </a:xfrm>
+          <a:prstGeom prst="roundRect">
+            <a:avLst>
+              <a:gd name="adj" fmla="val 6000"/>
+            </a:avLst>
+          </a:prstGeom>
+          <a:solidFill>
+            <a:srgbClr val="F8FAFC"/>
+          </a:solidFill>
+          <a:ln w="12700">
+            <a:solidFill>
+              <a:srgbClr val="E2E8F0"/>
+            </a:solidFill>
+          </a:ln>
+          <a:effectLst/>
+        </p:spPr>
+        <p:style>
+          <a:lnRef idx="1">
+            <a:schemeClr val="accent1"/>
+          </a:lnRef>
+          <a:fillRef idx="3">
+            <a:schemeClr val="accent1"/>
+          </a:fillRef>
+          <a:effectRef idx="2">
+            <a:schemeClr val="accent1"/>
+          </a:effectRef>
+          <a:fontRef idx="minor">
+            <a:schemeClr val="lt1"/>
+          </a:fontRef>
+        </p:style>
+        <p:txBody>
+          <a:bodyPr rtlCol="0" anchor="ctr"/>
+          <a:lstStyle/>
+          <a:p>
+            <a:pPr algn="ctr"/>
+          </a:p>
+        </p:txBody>
+      </p:sp>
+      <p:sp>
+        <p:nvSpPr>
+          <p:cNvPr id="5" name="TextBox 4"/>
+          <p:cNvSpPr txBox="1"/>
+          <p:nvPr/>
+        </p:nvSpPr>
+        <p:spPr>
+          <a:xfrm>
+            <a:off x="749808" y="1828800"/>
+            <a:ext cx="3163824" cy="731520"/>
+          </a:xfrm>
+          <a:prstGeom prst="rect">
+            <a:avLst/>
+          </a:prstGeom>
+          <a:noFill/>
+        </p:spPr>
+        <p:txBody>
+          <a:bodyPr wrap="square" anchor="t">
+            <a:spAutoFit/>
+          </a:bodyPr>
+          <a:lstStyle/>
+          <a:p>
+            <a:pPr algn="l"/>
+            <a:r>
+              <a:rPr sz="1800" b="1" i="0">
+                <a:solidFill>
+                  <a:srgbClr val="0284C7"/>
+                </a:solidFill>
+                <a:latin typeface="Calibri"/>
+              </a:rPr>
+              <a:t>Resilient</a:t>
+            </a:r>
+          </a:p>
+        </p:txBody>
+      </p:sp>
+      <p:sp>
+        <p:nvSpPr>
+          <p:cNvPr id="6" name="TextBox 5"/>
+          <p:cNvSpPr txBox="1"/>
+          <p:nvPr/>
+        </p:nvSpPr>
+        <p:spPr>
+          <a:xfrm>
+            <a:off x="749808" y="2697480"/>
+            <a:ext cx="3163824" cy="2194560"/>
+          </a:xfrm>
+          <a:prstGeom prst="rect">
+            <a:avLst/>
+          </a:prstGeom>
+          <a:noFill/>
+        </p:spPr>
+        <p:txBody>
+          <a:bodyPr wrap="square" anchor="t">
+            <a:spAutoFit/>
+          </a:bodyPr>
+          <a:lstStyle/>
+          <a:p>
+            <a:pPr algn="l"/>
+            <a:r>
+              <a:rPr sz="1500" b="0" i="0">
+                <a:solidFill>
+                  <a:srgbClr val="0F172A"/>
+                </a:solidFill>
+                <a:latin typeface="Calibri"/>
+              </a:rPr>
+              <a:t>Feed dies → watchdog advisory. Network dies → earliest tier + paper plan. Three channels: Telegram · SMS · Paper.</a:t>
+            </a:r>
+          </a:p>
+        </p:txBody>
+      </p:sp>
+      <p:sp>
+        <p:nvSpPr>
+          <p:cNvPr id="7" name="TextBox 6"/>
+          <p:cNvSpPr txBox="1"/>
+          <p:nvPr/>
+        </p:nvSpPr>
+        <p:spPr>
+          <a:xfrm>
+            <a:off x="749808" y="5029200"/>
+            <a:ext cx="3163824" cy="640080"/>
+          </a:xfrm>
+          <a:prstGeom prst="rect">
+            <a:avLst/>
+          </a:prstGeom>
+          <a:noFill/>
+        </p:spPr>
+        <p:txBody>
+          <a:bodyPr wrap="square" anchor="t">
+            <a:spAutoFit/>
+          </a:bodyPr>
+          <a:lstStyle/>
+          <a:p>
+            <a:pPr algn="l"/>
+            <a:r>
+              <a:rPr sz="1200" b="0" i="1">
+                <a:solidFill>
+                  <a:srgbClr val="475569"/>
+                </a:solidFill>
+                <a:latin typeface="Calibri"/>
+              </a:rPr>
+              <a:t>power, phones, roads — no single point of failure</a:t>
+            </a:r>
+          </a:p>
+        </p:txBody>
+      </p:sp>
+      <p:sp>
+        <p:nvSpPr>
+          <p:cNvPr id="8" name="Rounded Rectangle 7"/>
+          <p:cNvSpPr/>
+          <p:nvPr/>
+        </p:nvSpPr>
+        <p:spPr>
+          <a:xfrm>
+            <a:off x="4274820" y="1645920"/>
+            <a:ext cx="3566160" cy="4114800"/>
+          </a:xfrm>
+          <a:prstGeom prst="roundRect">
+            <a:avLst>
+              <a:gd name="adj" fmla="val 6000"/>
+            </a:avLst>
+          </a:prstGeom>
+          <a:solidFill>
+            <a:srgbClr val="F8FAFC"/>
+          </a:solidFill>
+          <a:ln w="12700">
+            <a:solidFill>
+              <a:srgbClr val="E2E8F0"/>
+            </a:solidFill>
+          </a:ln>
+          <a:effectLst/>
+        </p:spPr>
+        <p:style>
+          <a:lnRef idx="1">
+            <a:schemeClr val="accent1"/>
+          </a:lnRef>
+          <a:fillRef idx="3">
+            <a:schemeClr val="accent1"/>
+          </a:fillRef>
+          <a:effectRef idx="2">
+            <a:schemeClr val="accent1"/>
+          </a:effectRef>
+          <a:fontRef idx="minor">
+            <a:schemeClr val="lt1"/>
+          </a:fontRef>
+        </p:style>
+        <p:txBody>
+          <a:bodyPr rtlCol="0" anchor="ctr"/>
+          <a:lstStyle/>
+          <a:p>
+            <a:pPr algn="ctr"/>
+          </a:p>
+        </p:txBody>
+      </p:sp>
+      <p:sp>
+        <p:nvSpPr>
+          <p:cNvPr id="9" name="TextBox 8"/>
+          <p:cNvSpPr txBox="1"/>
+          <p:nvPr/>
+        </p:nvSpPr>
+        <p:spPr>
+          <a:xfrm>
+            <a:off x="4475988" y="1828800"/>
+            <a:ext cx="3163824" cy="731520"/>
+          </a:xfrm>
+          <a:prstGeom prst="rect">
+            <a:avLst/>
+          </a:prstGeom>
+          <a:noFill/>
+        </p:spPr>
+        <p:txBody>
+          <a:bodyPr wrap="square" anchor="t">
+            <a:spAutoFit/>
+          </a:bodyPr>
+          <a:lstStyle/>
+          <a:p>
+            <a:pPr algn="l"/>
+            <a:r>
+              <a:rPr sz="1800" b="1" i="0">
+                <a:solidFill>
+                  <a:srgbClr val="0284C7"/>
+                </a:solidFill>
+                <a:latin typeface="Calibri"/>
+              </a:rPr>
+              <a:t>Fair by design</a:t>
+            </a:r>
+          </a:p>
+        </p:txBody>
+      </p:sp>
+      <p:sp>
+        <p:nvSpPr>
+          <p:cNvPr id="10" name="TextBox 9"/>
+          <p:cNvSpPr txBox="1"/>
+          <p:nvPr/>
+        </p:nvSpPr>
+        <p:spPr>
+          <a:xfrm>
+            <a:off x="4475988" y="2697480"/>
+            <a:ext cx="3163824" cy="2194560"/>
+          </a:xfrm>
+          <a:prstGeom prst="rect">
+            <a:avLst/>
+          </a:prstGeom>
+          <a:noFill/>
+        </p:spPr>
+        <p:txBody>
+          <a:bodyPr wrap="square" anchor="t">
+            <a:spAutoFit/>
+          </a:bodyPr>
+          <a:lstStyle/>
+          <a:p>
+            <a:pPr algn="l"/>
+            <a:r>
+              <a:rPr sz="1500" b="0" i="0">
+                <a:solidFill>
+                  <a:srgbClr val="0F172A"/>
+                </a:solidFill>
+                <a:latin typeface="Calibri"/>
+              </a:rPr>
+              <a:t>Insurer + council funding subsidises the shops least able to pay. The owner owns their data.</a:t>
+            </a:r>
+          </a:p>
+        </p:txBody>
+      </p:sp>
+      <p:sp>
+        <p:nvSpPr>
+          <p:cNvPr id="11" name="TextBox 10"/>
+          <p:cNvSpPr txBox="1"/>
+          <p:nvPr/>
+        </p:nvSpPr>
+        <p:spPr>
+          <a:xfrm>
+            <a:off x="4475988" y="5029200"/>
+            <a:ext cx="3163824" cy="640080"/>
+          </a:xfrm>
+          <a:prstGeom prst="rect">
+            <a:avLst/>
+          </a:prstGeom>
+          <a:noFill/>
+        </p:spPr>
+        <p:txBody>
+          <a:bodyPr wrap="square" anchor="t">
+            <a:spAutoFit/>
+          </a:bodyPr>
+          <a:lstStyle/>
+          <a:p>
+            <a:pPr algn="l"/>
+            <a:r>
+              <a:rPr sz="1200" b="0" i="1">
+                <a:solidFill>
+                  <a:srgbClr val="475569"/>
+                </a:solidFill>
+                <a:latin typeface="Calibri"/>
+              </a:rPr>
+              <a:t>a warning you need resources to act on is regressive</a:t>
+            </a:r>
+          </a:p>
+        </p:txBody>
+      </p:sp>
+      <p:sp>
+        <p:nvSpPr>
+          <p:cNvPr id="12" name="Rounded Rectangle 11"/>
+          <p:cNvSpPr/>
+          <p:nvPr/>
+        </p:nvSpPr>
+        <p:spPr>
+          <a:xfrm>
+            <a:off x="8001000" y="1645920"/>
+            <a:ext cx="3566160" cy="4114800"/>
+          </a:xfrm>
+          <a:prstGeom prst="roundRect">
+            <a:avLst>
+              <a:gd name="adj" fmla="val 6000"/>
+            </a:avLst>
+          </a:prstGeom>
+          <a:solidFill>
+            <a:srgbClr val="F8FAFC"/>
+          </a:solidFill>
+          <a:ln w="12700">
+            <a:solidFill>
+              <a:srgbClr val="E2E8F0"/>
+            </a:solidFill>
+          </a:ln>
+          <a:effectLst/>
+        </p:spPr>
+        <p:style>
+          <a:lnRef idx="1">
+            <a:schemeClr val="accent1"/>
+          </a:lnRef>
+          <a:fillRef idx="3">
+            <a:schemeClr val="accent1"/>
+          </a:fillRef>
+          <a:effectRef idx="2">
+            <a:schemeClr val="accent1"/>
+          </a:effectRef>
+          <a:fontRef idx="minor">
+            <a:schemeClr val="lt1"/>
+          </a:fontRef>
+        </p:style>
+        <p:txBody>
+          <a:bodyPr rtlCol="0" anchor="ctr"/>
+          <a:lstStyle/>
+          <a:p>
+            <a:pPr algn="ctr"/>
+          </a:p>
+        </p:txBody>
+      </p:sp>
+      <p:sp>
+        <p:nvSpPr>
+          <p:cNvPr id="13" name="TextBox 12"/>
+          <p:cNvSpPr txBox="1"/>
+          <p:nvPr/>
+        </p:nvSpPr>
+        <p:spPr>
+          <a:xfrm>
+            <a:off x="8202168" y="1828800"/>
+            <a:ext cx="3163824" cy="731520"/>
+          </a:xfrm>
+          <a:prstGeom prst="rect">
+            <a:avLst/>
+          </a:prstGeom>
+          <a:noFill/>
+        </p:spPr>
+        <p:txBody>
+          <a:bodyPr wrap="square" anchor="t">
+            <a:spAutoFit/>
+          </a:bodyPr>
+          <a:lstStyle/>
+          <a:p>
+            <a:pPr algn="l"/>
+            <a:r>
+              <a:rPr sz="1800" b="1" i="0">
+                <a:solidFill>
+                  <a:srgbClr val="0284C7"/>
+                </a:solidFill>
+                <a:latin typeface="Calibri"/>
+              </a:rPr>
+              <a:t>Consequences we designed against</a:t>
+            </a:r>
+          </a:p>
+        </p:txBody>
+      </p:sp>
+      <p:sp>
+        <p:nvSpPr>
+          <p:cNvPr id="14" name="TextBox 13"/>
+          <p:cNvSpPr txBox="1"/>
+          <p:nvPr/>
+        </p:nvSpPr>
+        <p:spPr>
+          <a:xfrm>
+            <a:off x="8202168" y="2697480"/>
+            <a:ext cx="3163824" cy="2194560"/>
+          </a:xfrm>
+          <a:prstGeom prst="rect">
+            <a:avLst/>
+          </a:prstGeom>
+          <a:noFill/>
+        </p:spPr>
+        <p:txBody>
+          <a:bodyPr wrap="square" anchor="t">
+            <a:spAutoFit/>
+          </a:bodyPr>
+          <a:lstStyle/>
+          <a:p>
+            <a:pPr algn="l"/>
+            <a:r>
+              <a:rPr sz="1500" b="0" i="0">
+                <a:solidFill>
+                  <a:srgbClr val="0F172A"/>
+                </a:solidFill>
+                <a:latin typeface="Calibri"/>
+              </a:rPr>
+              <a:t>Redlining → we sell resilience, not risk-scoring for exclusion. Digital divide → SMS + paper. Alert fatigue → tiered debounce + owner in control.</a:t>
+            </a:r>
+          </a:p>
+        </p:txBody>
+      </p:sp>
+      <p:sp>
+        <p:nvSpPr>
+          <p:cNvPr id="15" name="TextBox 14"/>
+          <p:cNvSpPr txBox="1"/>
+          <p:nvPr/>
+        </p:nvSpPr>
+        <p:spPr>
+          <a:xfrm>
+            <a:off x="8202168" y="5029200"/>
+            <a:ext cx="3163824" cy="640080"/>
+          </a:xfrm>
+          <a:prstGeom prst="rect">
+            <a:avLst/>
+          </a:prstGeom>
+          <a:noFill/>
+        </p:spPr>
+        <p:txBody>
+          <a:bodyPr wrap="square" anchor="t">
+            <a:spAutoFit/>
+          </a:bodyPr>
+          <a:lstStyle/>
+          <a:p>
+            <a:pPr algn="l"/>
+            <a:r>
+              <a:rPr sz="1200" b="0" i="1">
+                <a:solidFill>
+                  <a:srgbClr val="475569"/>
+                </a:solidFill>
+                <a:latin typeface="Calibri"/>
+              </a:rPr>
+              <a:t>a holistic lens anticipates the harm, not just the good</a:t>
+            </a:r>
+          </a:p>
+        </p:txBody>
+      </p:sp>
+      <p:sp>
+        <p:nvSpPr>
+          <p:cNvPr id="16" name="TextBox 15"/>
+          <p:cNvSpPr txBox="1"/>
+          <p:nvPr/>
+        </p:nvSpPr>
+        <p:spPr>
+          <a:xfrm>
+            <a:off x="548640" y="6446520"/>
+            <a:ext cx="11091672" cy="320040"/>
+          </a:xfrm>
+          <a:prstGeom prst="rect">
+            <a:avLst/>
+          </a:prstGeom>
+          <a:noFill/>
+        </p:spPr>
+        <p:txBody>
+          <a:bodyPr wrap="square" anchor="t">
+            <a:spAutoFit/>
+          </a:bodyPr>
+          <a:lstStyle/>
+          <a:p>
+            <a:pPr algn="l"/>
+            <a:r>
+              <a:rPr sz="1100" b="0" i="0">
+                <a:solidFill>
+                  <a:srgbClr val="475569"/>
+                </a:solidFill>
+                <a:latin typeface="Calibri"/>
+              </a:rPr>
+              <a:t>BanjirKawan · Climate Systems Hackathon 2026</a:t>
+            </a:r>
+          </a:p>
+        </p:txBody>
+      </p:sp>
+    </p:spTree>
+  </p:cSld>
+  <p:clrMapOvr>
+    <a:masterClrMapping/>
+  </p:clrMapOvr>
+</p:sld>
+</file>
+
+<file path=ppt/slides/slide11.xml><?xml version="1.0" encoding="utf-8"?>
+<p:sld xmlns:a="http://schemas.openxmlformats.org/drawingml/2006/main" xmlns:p="http://schemas.openxmlformats.org/presentationml/2006/main" xmlns:r="http://schemas.openxmlformats.org/officeDocument/2006/relationships">
+  <p:cSld>
+    <p:spTree>
+      <p:nvGrpSpPr>
+        <p:cNvPr id="1" name=""/>
+        <p:cNvGrpSpPr/>
+        <p:nvPr/>
+      </p:nvGrpSpPr>
+      <p:grpSpPr/>
+      <p:sp>
+        <p:nvSpPr>
+          <p:cNvPr id="2" name="Rectangle 1"/>
+          <p:cNvSpPr/>
+          <p:nvPr/>
+        </p:nvSpPr>
+        <p:spPr>
+          <a:xfrm>
+            <a:off x="0" y="0"/>
+            <a:ext cx="12191695" cy="6858000"/>
+          </a:xfrm>
+          <a:prstGeom prst="rect">
+            <a:avLst/>
+          </a:prstGeom>
+          <a:solidFill>
             <a:srgbClr val="F8FAFC"/>
           </a:solidFill>
           <a:ln>
@@ -7239,7 +7900,7 @@
         </p:nvSpPr>
         <p:spPr>
           <a:xfrm>
-            <a:off x="548640" y="4617720"/>
+            <a:off x="548640" y="4434840"/>
             <a:ext cx="11091672" cy="914400"/>
           </a:xfrm>
           <a:prstGeom prst="rect">
@@ -7255,7 +7916,7 @@
           <a:p>
             <a:pPr algn="ctr"/>
             <a:r>
-              <a:rPr sz="6000" b="1" i="0">
+              <a:rPr sz="5600" b="1" i="0">
                 <a:solidFill>
                   <a:srgbClr val="0F172A"/>
                 </a:solidFill>
@@ -7274,8 +7935,8 @@
         </p:nvSpPr>
         <p:spPr>
           <a:xfrm>
-            <a:off x="548640" y="5715000"/>
-            <a:ext cx="11091672" cy="457200"/>
+            <a:off x="548640" y="5440680"/>
+            <a:ext cx="11091672" cy="365760"/>
           </a:xfrm>
           <a:prstGeom prst="rect">
             <a:avLst/>
@@ -7290,7 +7951,7 @@
           <a:p>
             <a:pPr algn="ctr"/>
             <a:r>
-              <a:rPr sz="1600" b="0" i="0">
+              <a:rPr sz="1500" b="0" i="0">
                 <a:solidFill>
                   <a:srgbClr val="475569"/>
                 </a:solidFill>
@@ -7303,7 +7964,59 @@
       </p:sp>
       <p:sp>
         <p:nvSpPr>
-          <p:cNvPr id="23" name="TextBox 22"/>
+          <p:cNvPr id="23" name="Rectangle 22"/>
+          <p:cNvSpPr/>
+          <p:nvPr/>
+        </p:nvSpPr>
+        <p:spPr>
+          <a:xfrm>
+            <a:off x="548640" y="5897880"/>
+            <a:ext cx="11091672" cy="411480"/>
+          </a:xfrm>
+          <a:prstGeom prst="rect">
+            <a:avLst/>
+          </a:prstGeom>
+          <a:solidFill>
+            <a:srgbClr val="0284C7"/>
+          </a:solidFill>
+          <a:ln>
+            <a:noFill/>
+          </a:ln>
+        </p:spPr>
+        <p:style>
+          <a:lnRef idx="1">
+            <a:schemeClr val="accent1"/>
+          </a:lnRef>
+          <a:fillRef idx="3">
+            <a:schemeClr val="accent1"/>
+          </a:fillRef>
+          <a:effectRef idx="2">
+            <a:schemeClr val="accent1"/>
+          </a:effectRef>
+          <a:fontRef idx="minor">
+            <a:schemeClr val="lt1"/>
+          </a:fontRef>
+        </p:style>
+        <p:txBody>
+          <a:bodyPr rtlCol="0" anchor="ctr"/>
+          <a:lstStyle/>
+          <a:p>
+            <a:pPr algn="ctr"/>
+            <a:r>
+              <a:rPr sz="1400" i="1">
+                <a:solidFill>
+                  <a:srgbClr val="FFFFFF"/>
+                </a:solidFill>
+                <a:latin typeface="Calibri"/>
+              </a:rPr>
+              <a:t>… but each ringgit is also a livelihood, a job, a family's debt — social costs that hit the most vulnerable hardest.</a:t>
+            </a:r>
+          </a:p>
+        </p:txBody>
+      </p:sp>
+      <p:sp>
+        <p:nvSpPr>
+          <p:cNvPr id="24" name="TextBox 23"/>
           <p:cNvSpPr txBox="1"/>
           <p:nvPr/>
         </p:nvSpPr>
@@ -10214,7 +10927,7 @@
                 </a:solidFill>
                 <a:latin typeface="Calibri"/>
               </a:rPr>
-              <a:t>Built as a system, not an app</a:t>
+              <a:t>Root cause, not symptom</a:t>
             </a:r>
           </a:p>
         </p:txBody>
@@ -10227,8 +10940,8 @@
         </p:nvSpPr>
         <p:spPr>
           <a:xfrm>
-            <a:off x="548640" y="1645920"/>
-            <a:ext cx="5303520" cy="1051560"/>
+            <a:off x="548640" y="1554480"/>
+            <a:ext cx="5394960" cy="1691640"/>
           </a:xfrm>
           <a:prstGeom prst="roundRect">
             <a:avLst>
@@ -10236,7 +10949,159 @@
             </a:avLst>
           </a:prstGeom>
           <a:solidFill>
-            <a:srgbClr val="DCFCE7"/>
+            <a:srgbClr val="F8FAFC"/>
+          </a:solidFill>
+          <a:ln w="12700">
+            <a:solidFill>
+              <a:srgbClr val="E2E8F0"/>
+            </a:solidFill>
+          </a:ln>
+          <a:effectLst/>
+        </p:spPr>
+        <p:style>
+          <a:lnRef idx="1">
+            <a:schemeClr val="accent1"/>
+          </a:lnRef>
+          <a:fillRef idx="3">
+            <a:schemeClr val="accent1"/>
+          </a:fillRef>
+          <a:effectRef idx="2">
+            <a:schemeClr val="accent1"/>
+          </a:effectRef>
+          <a:fontRef idx="minor">
+            <a:schemeClr val="lt1"/>
+          </a:fontRef>
+        </p:style>
+        <p:txBody>
+          <a:bodyPr rtlCol="0" anchor="ctr"/>
+          <a:lstStyle/>
+          <a:p>
+            <a:pPr algn="ctr"/>
+          </a:p>
+        </p:txBody>
+      </p:sp>
+      <p:sp>
+        <p:nvSpPr>
+          <p:cNvPr id="5" name="TextBox 4"/>
+          <p:cNvSpPr txBox="1"/>
+          <p:nvPr/>
+        </p:nvSpPr>
+        <p:spPr>
+          <a:xfrm>
+            <a:off x="777240" y="1673352"/>
+            <a:ext cx="4937760" cy="365760"/>
+          </a:xfrm>
+          <a:prstGeom prst="rect">
+            <a:avLst/>
+          </a:prstGeom>
+          <a:noFill/>
+        </p:spPr>
+        <p:txBody>
+          <a:bodyPr wrap="square" anchor="t">
+            <a:spAutoFit/>
+          </a:bodyPr>
+          <a:lstStyle/>
+          <a:p>
+            <a:pPr algn="l"/>
+            <a:r>
+              <a:rPr sz="1600" b="1" i="0">
+                <a:solidFill>
+                  <a:srgbClr val="0F172A"/>
+                </a:solidFill>
+                <a:latin typeface="Calibri"/>
+              </a:rPr>
+              <a:t>“Shifting the Burden” archetype</a:t>
+            </a:r>
+          </a:p>
+        </p:txBody>
+      </p:sp>
+      <p:sp>
+        <p:nvSpPr>
+          <p:cNvPr id="6" name="Rounded Rectangle 5"/>
+          <p:cNvSpPr/>
+          <p:nvPr/>
+        </p:nvSpPr>
+        <p:spPr>
+          <a:xfrm>
+            <a:off x="777240" y="2103120"/>
+            <a:ext cx="2286000" cy="658368"/>
+          </a:xfrm>
+          <a:prstGeom prst="roundRect">
+            <a:avLst>
+              <a:gd name="adj" fmla="val 6000"/>
+            </a:avLst>
+          </a:prstGeom>
+          <a:solidFill>
+            <a:srgbClr val="F1F5F9"/>
+          </a:solidFill>
+          <a:ln w="12700">
+            <a:solidFill>
+              <a:srgbClr val="E2E8F0"/>
+            </a:solidFill>
+          </a:ln>
+          <a:effectLst/>
+        </p:spPr>
+        <p:style>
+          <a:lnRef idx="1">
+            <a:schemeClr val="accent1"/>
+          </a:lnRef>
+          <a:fillRef idx="3">
+            <a:schemeClr val="accent1"/>
+          </a:fillRef>
+          <a:effectRef idx="2">
+            <a:schemeClr val="accent1"/>
+          </a:effectRef>
+          <a:fontRef idx="minor">
+            <a:schemeClr val="lt1"/>
+          </a:fontRef>
+        </p:style>
+        <p:txBody>
+          <a:bodyPr rtlCol="0" anchor="ctr" wrap="square"/>
+          <a:lstStyle/>
+          <a:p>
+            <a:pPr algn="ctr"/>
+            <a:r>
+              <a:rPr sz="1300" b="0" i="0">
+                <a:solidFill>
+                  <a:srgbClr val="0F172A"/>
+                </a:solidFill>
+                <a:latin typeface="Calibri"/>
+              </a:rPr>
+              <a:t>Symptom fix:</a:t>
+            </a:r>
+          </a:p>
+          <a:p>
+            <a:pPr algn="ctr"/>
+            <a:r>
+              <a:rPr sz="1300" b="0" i="0">
+                <a:solidFill>
+                  <a:srgbClr val="0F172A"/>
+                </a:solidFill>
+                <a:latin typeface="Calibri"/>
+              </a:rPr>
+              <a:t>relief + loans (after)</a:t>
+            </a:r>
+          </a:p>
+        </p:txBody>
+      </p:sp>
+      <p:sp>
+        <p:nvSpPr>
+          <p:cNvPr id="7" name="Rounded Rectangle 6"/>
+          <p:cNvSpPr/>
+          <p:nvPr/>
+        </p:nvSpPr>
+        <p:spPr>
+          <a:xfrm>
+            <a:off x="3566160" y="2103120"/>
+            <a:ext cx="2148840" cy="658368"/>
+          </a:xfrm>
+          <a:prstGeom prst="roundRect">
+            <a:avLst>
+              <a:gd name="adj" fmla="val 6000"/>
+            </a:avLst>
+          </a:prstGeom>
+          <a:solidFill>
+            <a:srgbClr val="0284C7"/>
           </a:solidFill>
           <a:ln>
             <a:noFill/>
@@ -10258,23 +11123,44 @@
           </a:fontRef>
         </p:style>
         <p:txBody>
-          <a:bodyPr rtlCol="0" anchor="ctr"/>
+          <a:bodyPr rtlCol="0" anchor="ctr" wrap="square"/>
           <a:lstStyle/>
           <a:p>
             <a:pPr algn="ctr"/>
-          </a:p>
-        </p:txBody>
-      </p:sp>
-      <p:sp>
-        <p:nvSpPr>
-          <p:cNvPr id="5" name="TextBox 4"/>
+            <a:r>
+              <a:rPr sz="1300" b="1" i="0">
+                <a:solidFill>
+                  <a:srgbClr val="FFFFFF"/>
+                </a:solidFill>
+                <a:latin typeface="Calibri"/>
+              </a:rPr>
+              <a:t>Fundamental:</a:t>
+            </a:r>
+          </a:p>
+          <a:p>
+            <a:pPr algn="ctr"/>
+            <a:r>
+              <a:rPr sz="1300" b="1" i="0">
+                <a:solidFill>
+                  <a:srgbClr val="FFFFFF"/>
+                </a:solidFill>
+                <a:latin typeface="Calibri"/>
+              </a:rPr>
+              <a:t>anticipation (before)</a:t>
+            </a:r>
+          </a:p>
+        </p:txBody>
+      </p:sp>
+      <p:sp>
+        <p:nvSpPr>
+          <p:cNvPr id="8" name="TextBox 7"/>
           <p:cNvSpPr txBox="1"/>
           <p:nvPr/>
         </p:nvSpPr>
         <p:spPr>
           <a:xfrm>
-            <a:off x="777240" y="1755648"/>
-            <a:ext cx="4937760" cy="320040"/>
+            <a:off x="777240" y="2816352"/>
+            <a:ext cx="4937760" cy="365760"/>
           </a:xfrm>
           <a:prstGeom prst="rect">
             <a:avLst/>
@@ -10289,27 +11175,73 @@
           <a:p>
             <a:pPr algn="l"/>
             <a:r>
-              <a:rPr sz="1400" b="1" i="0">
-                <a:solidFill>
-                  <a:srgbClr val="16A34A"/>
-                </a:solidFill>
-                <a:latin typeface="Calibri"/>
-              </a:rPr>
-              <a:t>BALANCING</a:t>
-            </a:r>
-          </a:p>
-        </p:txBody>
-      </p:sp>
-      <p:sp>
-        <p:nvSpPr>
-          <p:cNvPr id="6" name="TextBox 5"/>
+              <a:rPr sz="1300" b="0" i="1">
+                <a:solidFill>
+                  <a:srgbClr val="475569"/>
+                </a:solidFill>
+                <a:latin typeface="Calibri"/>
+              </a:rPr>
+              <a:t>Leaning on the quick fix lets real resilience wither.</a:t>
+            </a:r>
+          </a:p>
+        </p:txBody>
+      </p:sp>
+      <p:sp>
+        <p:nvSpPr>
+          <p:cNvPr id="9" name="Rounded Rectangle 8"/>
+          <p:cNvSpPr/>
+          <p:nvPr/>
+        </p:nvSpPr>
+        <p:spPr>
+          <a:xfrm>
+            <a:off x="548640" y="3429000"/>
+            <a:ext cx="5394960" cy="2423160"/>
+          </a:xfrm>
+          <a:prstGeom prst="roundRect">
+            <a:avLst>
+              <a:gd name="adj" fmla="val 6000"/>
+            </a:avLst>
+          </a:prstGeom>
+          <a:solidFill>
+            <a:srgbClr val="FEF2F2"/>
+          </a:solidFill>
+          <a:ln>
+            <a:noFill/>
+          </a:ln>
+          <a:effectLst/>
+        </p:spPr>
+        <p:style>
+          <a:lnRef idx="1">
+            <a:schemeClr val="accent1"/>
+          </a:lnRef>
+          <a:fillRef idx="3">
+            <a:schemeClr val="accent1"/>
+          </a:fillRef>
+          <a:effectRef idx="2">
+            <a:schemeClr val="accent1"/>
+          </a:effectRef>
+          <a:fontRef idx="minor">
+            <a:schemeClr val="lt1"/>
+          </a:fontRef>
+        </p:style>
+        <p:txBody>
+          <a:bodyPr rtlCol="0" anchor="ctr"/>
+          <a:lstStyle/>
+          <a:p>
+            <a:pPr algn="ctr"/>
+          </a:p>
+        </p:txBody>
+      </p:sp>
+      <p:sp>
+        <p:nvSpPr>
+          <p:cNvPr id="10" name="TextBox 9"/>
           <p:cNvSpPr txBox="1"/>
           <p:nvPr/>
         </p:nvSpPr>
         <p:spPr>
           <a:xfrm>
-            <a:off x="777240" y="2103120"/>
-            <a:ext cx="4937760" cy="548640"/>
+            <a:off x="777240" y="3547872"/>
+            <a:ext cx="4937760" cy="365760"/>
           </a:xfrm>
           <a:prstGeom prst="rect">
             <a:avLst/>
@@ -10324,27 +11256,97 @@
           <a:p>
             <a:pPr algn="l"/>
             <a:r>
-              <a:rPr sz="1600" b="0" i="0">
+              <a:rPr sz="1500" b="1" i="0">
+                <a:solidFill>
+                  <a:srgbClr val="DC2626"/>
+                </a:solidFill>
+                <a:latin typeface="Calibri"/>
+              </a:rPr>
+              <a:t>Vicious cycle (reinforcing)</a:t>
+            </a:r>
+          </a:p>
+        </p:txBody>
+      </p:sp>
+      <p:sp>
+        <p:nvSpPr>
+          <p:cNvPr id="11" name="TextBox 10"/>
+          <p:cNvSpPr txBox="1"/>
+          <p:nvPr/>
+        </p:nvSpPr>
+        <p:spPr>
+          <a:xfrm>
+            <a:off x="777240" y="3977639"/>
+            <a:ext cx="4937760" cy="1280160"/>
+          </a:xfrm>
+          <a:prstGeom prst="rect">
+            <a:avLst/>
+          </a:prstGeom>
+          <a:noFill/>
+        </p:spPr>
+        <p:txBody>
+          <a:bodyPr wrap="square" anchor="t">
+            <a:spAutoFit/>
+          </a:bodyPr>
+          <a:lstStyle/>
+          <a:p>
+            <a:pPr algn="l"/>
+            <a:r>
+              <a:rPr sz="1500" b="0" i="0">
                 <a:solidFill>
                   <a:srgbClr val="0F172A"/>
                 </a:solidFill>
                 <a:latin typeface="Calibri"/>
               </a:rPr>
-              <a:t>completed checklists → better playbooks (learns each monsoon)</a:t>
-            </a:r>
-          </a:p>
-        </p:txBody>
-      </p:sp>
-      <p:sp>
-        <p:nvSpPr>
-          <p:cNvPr id="7" name="Rounded Rectangle 6"/>
+              <a:t>flood → loss → debt → thinner buffer → next flood worse → closure / displacement → the neighbourhood loses its shop</a:t>
+            </a:r>
+          </a:p>
+        </p:txBody>
+      </p:sp>
+      <p:sp>
+        <p:nvSpPr>
+          <p:cNvPr id="12" name="TextBox 11"/>
+          <p:cNvSpPr txBox="1"/>
+          <p:nvPr/>
+        </p:nvSpPr>
+        <p:spPr>
+          <a:xfrm>
+            <a:off x="777240" y="5212080"/>
+            <a:ext cx="4937760" cy="548640"/>
+          </a:xfrm>
+          <a:prstGeom prst="rect">
+            <a:avLst/>
+          </a:prstGeom>
+          <a:noFill/>
+        </p:spPr>
+        <p:txBody>
+          <a:bodyPr wrap="square" anchor="t">
+            <a:spAutoFit/>
+          </a:bodyPr>
+          <a:lstStyle/>
+          <a:p>
+            <a:pPr algn="l"/>
+            <a:r>
+              <a:rPr sz="1300" b="0" i="0">
+                <a:solidFill>
+                  <a:srgbClr val="DC2626"/>
+                </a:solidFill>
+                <a:latin typeface="Calibri"/>
+              </a:rPr>
+              <a:t>Falls first on those least able to absorb it — uninsured, informal, women-run micro-shops.</a:t>
+            </a:r>
+          </a:p>
+        </p:txBody>
+      </p:sp>
+      <p:sp>
+        <p:nvSpPr>
+          <p:cNvPr id="13" name="Rounded Rectangle 12"/>
           <p:cNvSpPr/>
           <p:nvPr/>
         </p:nvSpPr>
         <p:spPr>
           <a:xfrm>
-            <a:off x="548640" y="2834640"/>
-            <a:ext cx="5303520" cy="1051560"/>
+            <a:off x="6126480" y="1554480"/>
+            <a:ext cx="5486400" cy="4297680"/>
           </a:xfrm>
           <a:prstGeom prst="roundRect">
             <a:avLst>
@@ -10383,14 +11385,14 @@
       </p:sp>
       <p:sp>
         <p:nvSpPr>
-          <p:cNvPr id="8" name="TextBox 7"/>
+          <p:cNvPr id="14" name="TextBox 13"/>
           <p:cNvSpPr txBox="1"/>
           <p:nvPr/>
         </p:nvSpPr>
         <p:spPr>
           <a:xfrm>
-            <a:off x="777240" y="2944368"/>
-            <a:ext cx="4937760" cy="320040"/>
+            <a:off x="6355080" y="1691640"/>
+            <a:ext cx="5029200" cy="365760"/>
           </a:xfrm>
           <a:prstGeom prst="rect">
             <a:avLst/>
@@ -10405,27 +11407,27 @@
           <a:p>
             <a:pPr algn="l"/>
             <a:r>
-              <a:rPr sz="1400" b="1" i="0">
+              <a:rPr sz="1600" b="1" i="0">
                 <a:solidFill>
                   <a:srgbClr val="0284C7"/>
                 </a:solidFill>
                 <a:latin typeface="Calibri"/>
               </a:rPr>
-              <a:t>REINFORCING</a:t>
-            </a:r>
-          </a:p>
-        </p:txBody>
-      </p:sp>
-      <p:sp>
-        <p:nvSpPr>
-          <p:cNvPr id="9" name="TextBox 8"/>
+              <a:t>We shift the intervention upstream — and reverse the loop</a:t>
+            </a:r>
+          </a:p>
+        </p:txBody>
+      </p:sp>
+      <p:sp>
+        <p:nvSpPr>
+          <p:cNvPr id="15" name="TextBox 14"/>
           <p:cNvSpPr txBox="1"/>
           <p:nvPr/>
         </p:nvSpPr>
         <p:spPr>
           <a:xfrm>
-            <a:off x="777240" y="3291840"/>
-            <a:ext cx="4937760" cy="548640"/>
+            <a:off x="6355080" y="2286000"/>
+            <a:ext cx="5029200" cy="2743200"/>
           </a:xfrm>
           <a:prstGeom prst="rect">
             <a:avLst/>
@@ -10440,282 +11442,55 @@
           <a:p>
             <a:pPr algn="l"/>
             <a:r>
-              <a:rPr sz="1600" b="0" i="0">
+              <a:rPr sz="1800" b="0" i="0">
                 <a:solidFill>
                   <a:srgbClr val="0F172A"/>
                 </a:solidFill>
                 <a:latin typeface="Calibri"/>
               </a:rPr>
-              <a:t>paid claims → trust → more shops (grows from use)</a:t>
-            </a:r>
-          </a:p>
-        </p:txBody>
-      </p:sp>
-      <p:graphicFrame>
-        <p:nvGraphicFramePr>
-          <p:cNvPr id="10" name="Table 9"/>
-          <p:cNvGraphicFramePr>
-            <a:graphicFrameLocks noGrp="1"/>
-          </p:cNvGraphicFramePr>
-          <p:nvPr/>
-        </p:nvGraphicFramePr>
-        <p:xfrm>
-          <a:off x="6126480" y="1645920"/>
-          <a:ext cx="5486400" cy="2377440"/>
-        </p:xfrm>
-        <a:graphic>
-          <a:graphicData uri="http://schemas.openxmlformats.org/drawingml/2006/table">
-            <a:tbl>
-              <a:tblPr firstRow="1" bandRow="1">
-                <a:tableStyleId>{5C22544A-7EE6-4342-B048-85BDC9FD1C3A}</a:tableStyleId>
-              </a:tblPr>
-              <a:tblGrid>
-                <a:gridCol w="1828800"/>
-                <a:gridCol w="3657600"/>
-              </a:tblGrid>
-              <a:tr h="594360">
-                <a:tc>
-                  <a:txBody>
-                    <a:bodyPr wrap="square"/>
-                    <a:lstStyle/>
-                    <a:p>
-                      <a:r>
-                        <a:rPr sz="1400" b="1">
-                          <a:solidFill>
-                            <a:srgbClr val="FFFFFF"/>
-                          </a:solidFill>
-                          <a:latin typeface="Calibri"/>
-                        </a:rPr>
-                        <a:t>If…</a:t>
-                      </a:r>
-                    </a:p>
-                  </a:txBody>
-                  <a:tcPr>
-                    <a:solidFill>
-                      <a:srgbClr val="0284C7"/>
-                    </a:solidFill>
-                  </a:tcPr>
-                </a:tc>
-                <a:tc>
-                  <a:txBody>
-                    <a:bodyPr wrap="square"/>
-                    <a:lstStyle/>
-                    <a:p>
-                      <a:r>
-                        <a:rPr sz="1400" b="1">
-                          <a:solidFill>
-                            <a:srgbClr val="FFFFFF"/>
-                          </a:solidFill>
-                          <a:latin typeface="Calibri"/>
-                        </a:rPr>
-                        <a:t>Then…</a:t>
-                      </a:r>
-                    </a:p>
-                  </a:txBody>
-                  <a:tcPr>
-                    <a:solidFill>
-                      <a:srgbClr val="0284C7"/>
-                    </a:solidFill>
-                  </a:tcPr>
-                </a:tc>
-              </a:tr>
-              <a:tr h="594360">
-                <a:tc>
-                  <a:txBody>
-                    <a:bodyPr wrap="square"/>
-                    <a:lstStyle/>
-                    <a:p>
-                      <a:r>
-                        <a:rPr sz="1300" b="0">
-                          <a:solidFill>
-                            <a:srgbClr val="0F172A"/>
-                          </a:solidFill>
-                          <a:latin typeface="Calibri"/>
-                        </a:rPr>
-                        <a:t>Data feed dies</a:t>
-                      </a:r>
-                    </a:p>
-                  </a:txBody>
-                  <a:tcPr>
-                    <a:solidFill>
-                      <a:srgbClr val="FFFFFF"/>
-                    </a:solidFill>
-                  </a:tcPr>
-                </a:tc>
-                <a:tc>
-                  <a:txBody>
-                    <a:bodyPr wrap="square"/>
-                    <a:lstStyle/>
-                    <a:p>
-                      <a:r>
-                        <a:rPr sz="1300" b="0">
-                          <a:solidFill>
-                            <a:srgbClr val="0F172A"/>
-                          </a:solidFill>
-                          <a:latin typeface="Calibri"/>
-                        </a:rPr>
-                        <a:t>Watchdog: treat heavy rain as a warning</a:t>
-                      </a:r>
-                    </a:p>
-                  </a:txBody>
-                  <a:tcPr>
-                    <a:solidFill>
-                      <a:srgbClr val="FFFFFF"/>
-                    </a:solidFill>
-                  </a:tcPr>
-                </a:tc>
-              </a:tr>
-              <a:tr h="594360">
-                <a:tc>
-                  <a:txBody>
-                    <a:bodyPr wrap="square"/>
-                    <a:lstStyle/>
-                    <a:p>
-                      <a:r>
-                        <a:rPr sz="1300" b="0">
-                          <a:solidFill>
-                            <a:srgbClr val="0F172A"/>
-                          </a:solidFill>
-                          <a:latin typeface="Calibri"/>
-                        </a:rPr>
-                        <a:t>Network dies</a:t>
-                      </a:r>
-                    </a:p>
-                  </a:txBody>
-                  <a:tcPr>
-                    <a:solidFill>
-                      <a:srgbClr val="FFFFFF"/>
-                    </a:solidFill>
-                  </a:tcPr>
-                </a:tc>
-                <a:tc>
-                  <a:txBody>
-                    <a:bodyPr wrap="square"/>
-                    <a:lstStyle/>
-                    <a:p>
-                      <a:r>
-                        <a:rPr sz="1300" b="0">
-                          <a:solidFill>
-                            <a:srgbClr val="0F172A"/>
-                          </a:solidFill>
-                          <a:latin typeface="Calibri"/>
-                        </a:rPr>
-                        <a:t>Earliest tier fired hours early + paper plan</a:t>
-                      </a:r>
-                    </a:p>
-                  </a:txBody>
-                  <a:tcPr>
-                    <a:solidFill>
-                      <a:srgbClr val="FFFFFF"/>
-                    </a:solidFill>
-                  </a:tcPr>
-                </a:tc>
-              </a:tr>
-              <a:tr h="594360">
-                <a:tc>
-                  <a:txBody>
-                    <a:bodyPr wrap="square"/>
-                    <a:lstStyle/>
-                    <a:p>
-                      <a:r>
-                        <a:rPr sz="1300" b="0">
-                          <a:solidFill>
-                            <a:srgbClr val="0F172A"/>
-                          </a:solidFill>
-                          <a:latin typeface="Calibri"/>
-                        </a:rPr>
-                        <a:t>Floods double</a:t>
-                      </a:r>
-                    </a:p>
-                  </a:txBody>
-                  <a:tcPr>
-                    <a:solidFill>
-                      <a:srgbClr val="FFFFFF"/>
-                    </a:solidFill>
-                  </a:tcPr>
-                </a:tc>
-                <a:tc>
-                  <a:txBody>
-                    <a:bodyPr wrap="square"/>
-                    <a:lstStyle/>
-                    <a:p>
-                      <a:r>
-                        <a:rPr sz="1300" b="0">
-                          <a:solidFill>
-                            <a:srgbClr val="0F172A"/>
-                          </a:solidFill>
-                          <a:latin typeface="Calibri"/>
-                        </a:rPr>
-                        <a:t>Marginal cost ≈ 0 — plans already cached</a:t>
-                      </a:r>
-                    </a:p>
-                  </a:txBody>
-                  <a:tcPr>
-                    <a:solidFill>
-                      <a:srgbClr val="FFFFFF"/>
-                    </a:solidFill>
-                  </a:tcPr>
-                </a:tc>
-              </a:tr>
-            </a:tbl>
-          </a:graphicData>
-        </a:graphic>
-      </p:graphicFrame>
-      <p:sp>
-        <p:nvSpPr>
-          <p:cNvPr id="11" name="Rectangle 10"/>
-          <p:cNvSpPr/>
-          <p:nvPr/>
-        </p:nvSpPr>
-        <p:spPr>
-          <a:xfrm>
-            <a:off x="548640" y="5394960"/>
-            <a:ext cx="11091672" cy="548640"/>
+              <a:t>early warning → action → less loss → telemetry-backed evidence → faster payout → trust → more shops protected → better data → better playbooks</a:t>
+            </a:r>
+          </a:p>
+        </p:txBody>
+      </p:sp>
+      <p:sp>
+        <p:nvSpPr>
+          <p:cNvPr id="16" name="TextBox 15"/>
+          <p:cNvSpPr txBox="1"/>
+          <p:nvPr/>
+        </p:nvSpPr>
+        <p:spPr>
+          <a:xfrm>
+            <a:off x="6355080" y="5257800"/>
+            <a:ext cx="5029200" cy="502920"/>
           </a:xfrm>
           <a:prstGeom prst="rect">
             <a:avLst/>
           </a:prstGeom>
-          <a:solidFill>
-            <a:srgbClr val="0284C7"/>
-          </a:solidFill>
-          <a:ln>
-            <a:noFill/>
-          </a:ln>
-        </p:spPr>
-        <p:style>
-          <a:lnRef idx="1">
-            <a:schemeClr val="accent1"/>
-          </a:lnRef>
-          <a:fillRef idx="3">
-            <a:schemeClr val="accent1"/>
-          </a:fillRef>
-          <a:effectRef idx="2">
-            <a:schemeClr val="accent1"/>
-          </a:effectRef>
-          <a:fontRef idx="minor">
-            <a:schemeClr val="lt1"/>
-          </a:fontRef>
-        </p:style>
-        <p:txBody>
-          <a:bodyPr rtlCol="0" anchor="ctr"/>
-          <a:lstStyle/>
-          <a:p>
-            <a:pPr algn="ctr"/>
-            <a:r>
-              <a:rPr sz="1800" b="1">
-                <a:solidFill>
-                  <a:srgbClr val="FFFFFF"/>
-                </a:solidFill>
-                <a:latin typeface="Calibri"/>
-              </a:rPr>
-              <a:t>3 channels — Telegram · SMS · Paper. No single point of failure.</a:t>
-            </a:r>
-          </a:p>
-        </p:txBody>
-      </p:sp>
-      <p:sp>
-        <p:nvSpPr>
-          <p:cNvPr id="12" name="TextBox 11"/>
+          <a:noFill/>
+        </p:spPr>
+        <p:txBody>
+          <a:bodyPr wrap="square" anchor="t">
+            <a:spAutoFit/>
+          </a:bodyPr>
+          <a:lstStyle/>
+          <a:p>
+            <a:pPr algn="l"/>
+            <a:r>
+              <a:rPr sz="1400" b="1" i="0">
+                <a:solidFill>
+                  <a:srgbClr val="0284C7"/>
+                </a:solidFill>
+                <a:latin typeface="Calibri"/>
+              </a:rPr>
+              <a:t>Same loop, run the other way. That is the leverage point.</a:t>
+            </a:r>
+          </a:p>
+        </p:txBody>
+      </p:sp>
+      <p:sp>
+        <p:nvSpPr>
+          <p:cNvPr id="17" name="TextBox 16"/>
           <p:cNvSpPr txBox="1"/>
           <p:nvPr/>
         </p:nvSpPr>

</xml_diff>

<commit_message>
feat(pitch): name the four resilience capacities and Climate-U co-creation
Reflect the webinar's own frameworks back to the panel on Slide 5:
- map the product to Anticipate / Absorb / Adapt / Recover ("bounce forward")
- make the participatory onboarding explicit as Climate-U co-creation
- update the Slide 5 script beat to match

Closes the last content gap before rehearsal; deck stays 11 slides.
</commit_message>
<xml_diff>
--- a/docs/BanjirKawan.pptx
+++ b/docs/BanjirKawan.pptx
@@ -932,7 +932,7 @@
           <a:lstStyle/>
           <a:p>
             <a:r>
-              <a:t>BanjirKawan. The design principle answers the brief's own systems angle — 'the fix needs power, phones and roads too' — so the AI is never in the storm path. On a dry day, AI vision turns five phone photos into a risk map of every asset — its height off the floor, its ringgit value — and the owner confirms it, so nothing is hallucinated. We pre-compute tiered action playbooks and cache them. When the flood comes, the alert path is dumb, deterministic code — threshold, cache lookup, send. And after the flood, five photos become an itemised claim report whose evidence is the river authority's own telemetry.</a:t>
+              <a:t>BanjirKawan. The design principle answers the brief's systems angle — the fix needs power, phones and roads too — so the AI is never in the storm path. On a dry day, AI vision turns five photos into a risk map of every asset, and — this matters — the owner confirms and corrects every one. It's participatory: built with the community, not imposed on it, which is the Climate-U co-creation value. We cache tiered playbooks. When the flood comes, the alert path is dumb, deterministic code — threshold, cache lookup, send. And notice the shape of the whole thing — it's the four resilience capacities: we help shops Anticipate with early warning, Absorb with a ranked playbook, Adapt through a learning loop that sharpens each monsoon, and Recover with a telemetry-backed claim report that lets them bounce forward, not just back.</a:t>
             </a:r>
           </a:p>
         </p:txBody>
@@ -8153,8 +8153,8 @@
         </p:nvSpPr>
         <p:spPr>
           <a:xfrm>
-            <a:off x="548640" y="1737360"/>
-            <a:ext cx="5212080" cy="2926080"/>
+            <a:off x="548640" y="1463040"/>
+            <a:ext cx="5212080" cy="2194560"/>
           </a:xfrm>
           <a:prstGeom prst="roundRect">
             <a:avLst>
@@ -8199,7 +8199,7 @@
         </p:nvSpPr>
         <p:spPr>
           <a:xfrm>
-            <a:off x="822960" y="1965960"/>
+            <a:off x="822960" y="1645920"/>
             <a:ext cx="4663440" cy="457200"/>
           </a:xfrm>
           <a:prstGeom prst="rect">
@@ -8234,8 +8234,8 @@
         </p:nvSpPr>
         <p:spPr>
           <a:xfrm>
-            <a:off x="822960" y="2560320"/>
-            <a:ext cx="4663440" cy="1828800"/>
+            <a:off x="822960" y="2240280"/>
+            <a:ext cx="4663440" cy="1280160"/>
           </a:xfrm>
           <a:prstGeom prst="rect">
             <a:avLst/>
@@ -8250,7 +8250,7 @@
           <a:p>
             <a:pPr algn="l"/>
             <a:r>
-              <a:rPr sz="1800" b="0" i="0">
+              <a:rPr sz="1700" b="0" i="0">
                 <a:solidFill>
                   <a:srgbClr val="0F172A"/>
                 </a:solidFill>
@@ -8269,8 +8269,8 @@
         </p:nvSpPr>
         <p:spPr>
           <a:xfrm>
-            <a:off x="6428232" y="1737360"/>
-            <a:ext cx="5212080" cy="2926080"/>
+            <a:off x="6428232" y="1463040"/>
+            <a:ext cx="5212080" cy="2194560"/>
           </a:xfrm>
           <a:prstGeom prst="roundRect">
             <a:avLst>
@@ -8315,7 +8315,7 @@
         </p:nvSpPr>
         <p:spPr>
           <a:xfrm>
-            <a:off x="6702552" y="1965960"/>
+            <a:off x="6702552" y="1645920"/>
             <a:ext cx="4663440" cy="457200"/>
           </a:xfrm>
           <a:prstGeom prst="rect">
@@ -8350,7 +8350,7 @@
         </p:nvSpPr>
         <p:spPr>
           <a:xfrm>
-            <a:off x="6702552" y="2560320"/>
+            <a:off x="6702552" y="2240280"/>
             <a:ext cx="4663440" cy="914400"/>
           </a:xfrm>
           <a:prstGeom prst="rect">
@@ -8366,7 +8366,7 @@
           <a:p>
             <a:pPr algn="l"/>
             <a:r>
-              <a:rPr sz="1800" b="0" i="0">
+              <a:rPr sz="1700" b="0" i="0">
                 <a:solidFill>
                   <a:srgbClr val="0F172A"/>
                 </a:solidFill>
@@ -8385,8 +8385,8 @@
         </p:nvSpPr>
         <p:spPr>
           <a:xfrm>
-            <a:off x="3108960" y="2971800"/>
-            <a:ext cx="5943600" cy="640080"/>
+            <a:off x="3108960" y="2651760"/>
+            <a:ext cx="5943600" cy="566928"/>
           </a:xfrm>
           <a:prstGeom prst="roundRect">
             <a:avLst>
@@ -8421,7 +8421,7 @@
           <a:p>
             <a:pPr algn="ctr"/>
             <a:r>
-              <a:rPr sz="1800" b="1" i="0">
+              <a:rPr sz="1700" b="1" i="0">
                 <a:solidFill>
                   <a:srgbClr val="FFFFFF"/>
                 </a:solidFill>
@@ -8440,8 +8440,8 @@
         </p:nvSpPr>
         <p:spPr>
           <a:xfrm>
-            <a:off x="548640" y="4937760"/>
-            <a:ext cx="11091672" cy="914400"/>
+            <a:off x="548640" y="3931920"/>
+            <a:ext cx="2651760" cy="1051560"/>
           </a:xfrm>
           <a:prstGeom prst="roundRect">
             <a:avLst>
@@ -8473,25 +8473,580 @@
           </a:fontRef>
         </p:style>
         <p:txBody>
-          <a:bodyPr rtlCol="0" anchor="ctr" wrap="square"/>
+          <a:bodyPr rtlCol="0" anchor="ctr"/>
+          <a:lstStyle/>
+          <a:p>
+            <a:pPr algn="ctr"/>
+          </a:p>
+        </p:txBody>
+      </p:sp>
+      <p:sp>
+        <p:nvSpPr>
+          <p:cNvPr id="12" name="TextBox 11"/>
+          <p:cNvSpPr txBox="1"/>
+          <p:nvPr/>
+        </p:nvSpPr>
+        <p:spPr>
+          <a:xfrm>
+            <a:off x="685800" y="4069080"/>
+            <a:ext cx="2377440" cy="411480"/>
+          </a:xfrm>
+          <a:prstGeom prst="rect">
+            <a:avLst/>
+          </a:prstGeom>
+          <a:noFill/>
+        </p:spPr>
+        <p:txBody>
+          <a:bodyPr wrap="square" anchor="t">
+            <a:spAutoFit/>
+          </a:bodyPr>
+          <a:lstStyle/>
+          <a:p>
+            <a:pPr algn="ctr"/>
+            <a:r>
+              <a:rPr sz="1600" b="1" i="0">
+                <a:solidFill>
+                  <a:srgbClr val="0284C7"/>
+                </a:solidFill>
+                <a:latin typeface="Calibri"/>
+              </a:rPr>
+              <a:t>Anticipate</a:t>
+            </a:r>
+          </a:p>
+        </p:txBody>
+      </p:sp>
+      <p:sp>
+        <p:nvSpPr>
+          <p:cNvPr id="13" name="TextBox 12"/>
+          <p:cNvSpPr txBox="1"/>
+          <p:nvPr/>
+        </p:nvSpPr>
+        <p:spPr>
+          <a:xfrm>
+            <a:off x="685800" y="4507992"/>
+            <a:ext cx="2377440" cy="411480"/>
+          </a:xfrm>
+          <a:prstGeom prst="rect">
+            <a:avLst/>
+          </a:prstGeom>
+          <a:noFill/>
+        </p:spPr>
+        <p:txBody>
+          <a:bodyPr wrap="square" anchor="t">
+            <a:spAutoFit/>
+          </a:bodyPr>
+          <a:lstStyle/>
+          <a:p>
+            <a:pPr algn="ctr"/>
+            <a:r>
+              <a:rPr sz="1200" b="0" i="0">
+                <a:solidFill>
+                  <a:srgbClr val="475569"/>
+                </a:solidFill>
+                <a:latin typeface="Calibri"/>
+              </a:rPr>
+              <a:t>dry-day survey + early warning</a:t>
+            </a:r>
+          </a:p>
+        </p:txBody>
+      </p:sp>
+      <p:sp>
+        <p:nvSpPr>
+          <p:cNvPr id="14" name="TextBox 13"/>
+          <p:cNvSpPr txBox="1"/>
+          <p:nvPr/>
+        </p:nvSpPr>
+        <p:spPr>
+          <a:xfrm>
+            <a:off x="3127248" y="4160520"/>
+            <a:ext cx="320040" cy="457200"/>
+          </a:xfrm>
+          <a:prstGeom prst="rect">
+            <a:avLst/>
+          </a:prstGeom>
+          <a:noFill/>
+        </p:spPr>
+        <p:txBody>
+          <a:bodyPr wrap="square" anchor="t">
+            <a:spAutoFit/>
+          </a:bodyPr>
           <a:lstStyle/>
           <a:p>
             <a:pPr algn="l"/>
             <a:r>
-              <a:rPr sz="1800" b="0" i="0">
+              <a:rPr sz="1800" b="1" i="0">
+                <a:solidFill>
+                  <a:srgbClr val="0284C7"/>
+                </a:solidFill>
+                <a:latin typeface="Calibri"/>
+              </a:rPr>
+              <a:t>→</a:t>
+            </a:r>
+          </a:p>
+        </p:txBody>
+      </p:sp>
+      <p:sp>
+        <p:nvSpPr>
+          <p:cNvPr id="15" name="Rounded Rectangle 14"/>
+          <p:cNvSpPr/>
+          <p:nvPr/>
+        </p:nvSpPr>
+        <p:spPr>
+          <a:xfrm>
+            <a:off x="3332988" y="3931920"/>
+            <a:ext cx="2651760" cy="1051560"/>
+          </a:xfrm>
+          <a:prstGeom prst="roundRect">
+            <a:avLst>
+              <a:gd name="adj" fmla="val 6000"/>
+            </a:avLst>
+          </a:prstGeom>
+          <a:solidFill>
+            <a:srgbClr val="F8FAFC"/>
+          </a:solidFill>
+          <a:ln w="12700">
+            <a:solidFill>
+              <a:srgbClr val="E2E8F0"/>
+            </a:solidFill>
+          </a:ln>
+          <a:effectLst/>
+        </p:spPr>
+        <p:style>
+          <a:lnRef idx="1">
+            <a:schemeClr val="accent1"/>
+          </a:lnRef>
+          <a:fillRef idx="3">
+            <a:schemeClr val="accent1"/>
+          </a:fillRef>
+          <a:effectRef idx="2">
+            <a:schemeClr val="accent1"/>
+          </a:effectRef>
+          <a:fontRef idx="minor">
+            <a:schemeClr val="lt1"/>
+          </a:fontRef>
+        </p:style>
+        <p:txBody>
+          <a:bodyPr rtlCol="0" anchor="ctr"/>
+          <a:lstStyle/>
+          <a:p>
+            <a:pPr algn="ctr"/>
+          </a:p>
+        </p:txBody>
+      </p:sp>
+      <p:sp>
+        <p:nvSpPr>
+          <p:cNvPr id="16" name="TextBox 15"/>
+          <p:cNvSpPr txBox="1"/>
+          <p:nvPr/>
+        </p:nvSpPr>
+        <p:spPr>
+          <a:xfrm>
+            <a:off x="3470148" y="4069080"/>
+            <a:ext cx="2377440" cy="411480"/>
+          </a:xfrm>
+          <a:prstGeom prst="rect">
+            <a:avLst/>
+          </a:prstGeom>
+          <a:noFill/>
+        </p:spPr>
+        <p:txBody>
+          <a:bodyPr wrap="square" anchor="t">
+            <a:spAutoFit/>
+          </a:bodyPr>
+          <a:lstStyle/>
+          <a:p>
+            <a:pPr algn="ctr"/>
+            <a:r>
+              <a:rPr sz="1600" b="1" i="0">
+                <a:solidFill>
+                  <a:srgbClr val="0284C7"/>
+                </a:solidFill>
+                <a:latin typeface="Calibri"/>
+              </a:rPr>
+              <a:t>Absorb</a:t>
+            </a:r>
+          </a:p>
+        </p:txBody>
+      </p:sp>
+      <p:sp>
+        <p:nvSpPr>
+          <p:cNvPr id="17" name="TextBox 16"/>
+          <p:cNvSpPr txBox="1"/>
+          <p:nvPr/>
+        </p:nvSpPr>
+        <p:spPr>
+          <a:xfrm>
+            <a:off x="3470148" y="4507992"/>
+            <a:ext cx="2377440" cy="411480"/>
+          </a:xfrm>
+          <a:prstGeom prst="rect">
+            <a:avLst/>
+          </a:prstGeom>
+          <a:noFill/>
+        </p:spPr>
+        <p:txBody>
+          <a:bodyPr wrap="square" anchor="t">
+            <a:spAutoFit/>
+          </a:bodyPr>
+          <a:lstStyle/>
+          <a:p>
+            <a:pPr algn="ctr"/>
+            <a:r>
+              <a:rPr sz="1200" b="0" i="0">
+                <a:solidFill>
+                  <a:srgbClr val="475569"/>
+                </a:solidFill>
+                <a:latin typeface="Calibri"/>
+              </a:rPr>
+              <a:t>ranked action playbook</a:t>
+            </a:r>
+          </a:p>
+        </p:txBody>
+      </p:sp>
+      <p:sp>
+        <p:nvSpPr>
+          <p:cNvPr id="18" name="TextBox 17"/>
+          <p:cNvSpPr txBox="1"/>
+          <p:nvPr/>
+        </p:nvSpPr>
+        <p:spPr>
+          <a:xfrm>
+            <a:off x="5911596" y="4160520"/>
+            <a:ext cx="320040" cy="457200"/>
+          </a:xfrm>
+          <a:prstGeom prst="rect">
+            <a:avLst/>
+          </a:prstGeom>
+          <a:noFill/>
+        </p:spPr>
+        <p:txBody>
+          <a:bodyPr wrap="square" anchor="t">
+            <a:spAutoFit/>
+          </a:bodyPr>
+          <a:lstStyle/>
+          <a:p>
+            <a:pPr algn="l"/>
+            <a:r>
+              <a:rPr sz="1800" b="1" i="0">
+                <a:solidFill>
+                  <a:srgbClr val="0284C7"/>
+                </a:solidFill>
+                <a:latin typeface="Calibri"/>
+              </a:rPr>
+              <a:t>→</a:t>
+            </a:r>
+          </a:p>
+        </p:txBody>
+      </p:sp>
+      <p:sp>
+        <p:nvSpPr>
+          <p:cNvPr id="19" name="Rounded Rectangle 18"/>
+          <p:cNvSpPr/>
+          <p:nvPr/>
+        </p:nvSpPr>
+        <p:spPr>
+          <a:xfrm>
+            <a:off x="6117336" y="3931920"/>
+            <a:ext cx="2651760" cy="1051560"/>
+          </a:xfrm>
+          <a:prstGeom prst="roundRect">
+            <a:avLst>
+              <a:gd name="adj" fmla="val 6000"/>
+            </a:avLst>
+          </a:prstGeom>
+          <a:solidFill>
+            <a:srgbClr val="F8FAFC"/>
+          </a:solidFill>
+          <a:ln w="12700">
+            <a:solidFill>
+              <a:srgbClr val="E2E8F0"/>
+            </a:solidFill>
+          </a:ln>
+          <a:effectLst/>
+        </p:spPr>
+        <p:style>
+          <a:lnRef idx="1">
+            <a:schemeClr val="accent1"/>
+          </a:lnRef>
+          <a:fillRef idx="3">
+            <a:schemeClr val="accent1"/>
+          </a:fillRef>
+          <a:effectRef idx="2">
+            <a:schemeClr val="accent1"/>
+          </a:effectRef>
+          <a:fontRef idx="minor">
+            <a:schemeClr val="lt1"/>
+          </a:fontRef>
+        </p:style>
+        <p:txBody>
+          <a:bodyPr rtlCol="0" anchor="ctr"/>
+          <a:lstStyle/>
+          <a:p>
+            <a:pPr algn="ctr"/>
+          </a:p>
+        </p:txBody>
+      </p:sp>
+      <p:sp>
+        <p:nvSpPr>
+          <p:cNvPr id="20" name="TextBox 19"/>
+          <p:cNvSpPr txBox="1"/>
+          <p:nvPr/>
+        </p:nvSpPr>
+        <p:spPr>
+          <a:xfrm>
+            <a:off x="6254496" y="4069080"/>
+            <a:ext cx="2377440" cy="411480"/>
+          </a:xfrm>
+          <a:prstGeom prst="rect">
+            <a:avLst/>
+          </a:prstGeom>
+          <a:noFill/>
+        </p:spPr>
+        <p:txBody>
+          <a:bodyPr wrap="square" anchor="t">
+            <a:spAutoFit/>
+          </a:bodyPr>
+          <a:lstStyle/>
+          <a:p>
+            <a:pPr algn="ctr"/>
+            <a:r>
+              <a:rPr sz="1600" b="1" i="0">
+                <a:solidFill>
+                  <a:srgbClr val="0284C7"/>
+                </a:solidFill>
+                <a:latin typeface="Calibri"/>
+              </a:rPr>
+              <a:t>Adapt</a:t>
+            </a:r>
+          </a:p>
+        </p:txBody>
+      </p:sp>
+      <p:sp>
+        <p:nvSpPr>
+          <p:cNvPr id="21" name="TextBox 20"/>
+          <p:cNvSpPr txBox="1"/>
+          <p:nvPr/>
+        </p:nvSpPr>
+        <p:spPr>
+          <a:xfrm>
+            <a:off x="6254496" y="4507992"/>
+            <a:ext cx="2377440" cy="411480"/>
+          </a:xfrm>
+          <a:prstGeom prst="rect">
+            <a:avLst/>
+          </a:prstGeom>
+          <a:noFill/>
+        </p:spPr>
+        <p:txBody>
+          <a:bodyPr wrap="square" anchor="t">
+            <a:spAutoFit/>
+          </a:bodyPr>
+          <a:lstStyle/>
+          <a:p>
+            <a:pPr algn="ctr"/>
+            <a:r>
+              <a:rPr sz="1200" b="0" i="0">
+                <a:solidFill>
+                  <a:srgbClr val="475569"/>
+                </a:solidFill>
+                <a:latin typeface="Calibri"/>
+              </a:rPr>
+              <a:t>learning loop each monsoon</a:t>
+            </a:r>
+          </a:p>
+        </p:txBody>
+      </p:sp>
+      <p:sp>
+        <p:nvSpPr>
+          <p:cNvPr id="22" name="TextBox 21"/>
+          <p:cNvSpPr txBox="1"/>
+          <p:nvPr/>
+        </p:nvSpPr>
+        <p:spPr>
+          <a:xfrm>
+            <a:off x="8695944" y="4160520"/>
+            <a:ext cx="320040" cy="457200"/>
+          </a:xfrm>
+          <a:prstGeom prst="rect">
+            <a:avLst/>
+          </a:prstGeom>
+          <a:noFill/>
+        </p:spPr>
+        <p:txBody>
+          <a:bodyPr wrap="square" anchor="t">
+            <a:spAutoFit/>
+          </a:bodyPr>
+          <a:lstStyle/>
+          <a:p>
+            <a:pPr algn="l"/>
+            <a:r>
+              <a:rPr sz="1800" b="1" i="0">
+                <a:solidFill>
+                  <a:srgbClr val="0284C7"/>
+                </a:solidFill>
+                <a:latin typeface="Calibri"/>
+              </a:rPr>
+              <a:t>→</a:t>
+            </a:r>
+          </a:p>
+        </p:txBody>
+      </p:sp>
+      <p:sp>
+        <p:nvSpPr>
+          <p:cNvPr id="23" name="Rounded Rectangle 22"/>
+          <p:cNvSpPr/>
+          <p:nvPr/>
+        </p:nvSpPr>
+        <p:spPr>
+          <a:xfrm>
+            <a:off x="8901684" y="3931920"/>
+            <a:ext cx="2651760" cy="1051560"/>
+          </a:xfrm>
+          <a:prstGeom prst="roundRect">
+            <a:avLst>
+              <a:gd name="adj" fmla="val 6000"/>
+            </a:avLst>
+          </a:prstGeom>
+          <a:solidFill>
+            <a:srgbClr val="F8FAFC"/>
+          </a:solidFill>
+          <a:ln w="12700">
+            <a:solidFill>
+              <a:srgbClr val="E2E8F0"/>
+            </a:solidFill>
+          </a:ln>
+          <a:effectLst/>
+        </p:spPr>
+        <p:style>
+          <a:lnRef idx="1">
+            <a:schemeClr val="accent1"/>
+          </a:lnRef>
+          <a:fillRef idx="3">
+            <a:schemeClr val="accent1"/>
+          </a:fillRef>
+          <a:effectRef idx="2">
+            <a:schemeClr val="accent1"/>
+          </a:effectRef>
+          <a:fontRef idx="minor">
+            <a:schemeClr val="lt1"/>
+          </a:fontRef>
+        </p:style>
+        <p:txBody>
+          <a:bodyPr rtlCol="0" anchor="ctr"/>
+          <a:lstStyle/>
+          <a:p>
+            <a:pPr algn="ctr"/>
+          </a:p>
+        </p:txBody>
+      </p:sp>
+      <p:sp>
+        <p:nvSpPr>
+          <p:cNvPr id="24" name="TextBox 23"/>
+          <p:cNvSpPr txBox="1"/>
+          <p:nvPr/>
+        </p:nvSpPr>
+        <p:spPr>
+          <a:xfrm>
+            <a:off x="9038844" y="4069080"/>
+            <a:ext cx="2377440" cy="411480"/>
+          </a:xfrm>
+          <a:prstGeom prst="rect">
+            <a:avLst/>
+          </a:prstGeom>
+          <a:noFill/>
+        </p:spPr>
+        <p:txBody>
+          <a:bodyPr wrap="square" anchor="t">
+            <a:spAutoFit/>
+          </a:bodyPr>
+          <a:lstStyle/>
+          <a:p>
+            <a:pPr algn="ctr"/>
+            <a:r>
+              <a:rPr sz="1600" b="1" i="0">
+                <a:solidFill>
+                  <a:srgbClr val="0284C7"/>
+                </a:solidFill>
+                <a:latin typeface="Calibri"/>
+              </a:rPr>
+              <a:t>Recover</a:t>
+            </a:r>
+          </a:p>
+        </p:txBody>
+      </p:sp>
+      <p:sp>
+        <p:nvSpPr>
+          <p:cNvPr id="25" name="TextBox 24"/>
+          <p:cNvSpPr txBox="1"/>
+          <p:nvPr/>
+        </p:nvSpPr>
+        <p:spPr>
+          <a:xfrm>
+            <a:off x="9038844" y="4507992"/>
+            <a:ext cx="2377440" cy="411480"/>
+          </a:xfrm>
+          <a:prstGeom prst="rect">
+            <a:avLst/>
+          </a:prstGeom>
+          <a:noFill/>
+        </p:spPr>
+        <p:txBody>
+          <a:bodyPr wrap="square" anchor="t">
+            <a:spAutoFit/>
+          </a:bodyPr>
+          <a:lstStyle/>
+          <a:p>
+            <a:pPr algn="ctr"/>
+            <a:r>
+              <a:rPr sz="1200" b="0" i="0">
+                <a:solidFill>
+                  <a:srgbClr val="475569"/>
+                </a:solidFill>
+                <a:latin typeface="Calibri"/>
+              </a:rPr>
+              <a:t>claim report → bounce forward</a:t>
+            </a:r>
+          </a:p>
+        </p:txBody>
+      </p:sp>
+      <p:sp>
+        <p:nvSpPr>
+          <p:cNvPr id="26" name="TextBox 25"/>
+          <p:cNvSpPr txBox="1"/>
+          <p:nvPr/>
+        </p:nvSpPr>
+        <p:spPr>
+          <a:xfrm>
+            <a:off x="548640" y="5166360"/>
+            <a:ext cx="11091672" cy="548640"/>
+          </a:xfrm>
+          <a:prstGeom prst="rect">
+            <a:avLst/>
+          </a:prstGeom>
+          <a:noFill/>
+        </p:spPr>
+        <p:txBody>
+          <a:bodyPr wrap="square" anchor="t">
+            <a:spAutoFit/>
+          </a:bodyPr>
+          <a:lstStyle/>
+          <a:p>
+            <a:pPr algn="ctr"/>
+            <a:r>
+              <a:rPr sz="1400" b="0" i="1">
                 <a:solidFill>
                   <a:srgbClr val="0F172A"/>
                 </a:solidFill>
                 <a:latin typeface="Calibri"/>
               </a:rPr>
-              <a:t>After the flood: 5 photos → claim report (evidence = river authority telemetry)</a:t>
-            </a:r>
-          </a:p>
-        </p:txBody>
-      </p:sp>
-      <p:sp>
-        <p:nvSpPr>
-          <p:cNvPr id="12" name="TextBox 11"/>
+              <a:t>Built WITH the community: AI proposes, the owner confirms every asset — participatory by design (Climate-U co-creation).</a:t>
+            </a:r>
+          </a:p>
+        </p:txBody>
+      </p:sp>
+      <p:sp>
+        <p:nvSpPr>
+          <p:cNvPr id="27" name="TextBox 26"/>
           <p:cNvSpPr txBox="1"/>
           <p:nvPr/>
         </p:nvSpPr>

</xml_diff>